<commit_message>
Add Chinese academic route templates
</commit_message>
<xml_diff>
--- a/examples/agent-workflow-demo/outputs/tech-route.pptx
+++ b/examples/agent-workflow-demo/outputs/tech-route.pptx
@@ -7,7 +7,7 @@
   <p:sldIdLst>
     <p:sldId id="256" r:id="rId2"/>
   </p:sldIdLst>
-  <p:sldSz cx="12192000" cy="6858000" type="wide"/>
+  <p:sldSz cx="12192000" cy="6858000" type="custom"/>
   <p:notesSz cx="6858000" cy="9144000"/>
 </p:presentation>
 </file>
@@ -93,8 +93,8 @@
         </p:nvSpPr>
         <p:spPr>
           <a:xfrm>
-            <a:off x="870000" y="857474"/>
-            <a:ext cx="10452000" cy="430000"/>
+            <a:off x="670000" y="857474"/>
+            <a:ext cx="10852000" cy="430000"/>
           </a:xfrm>
           <a:prstGeom prst="roundRect">
             <a:avLst/>
@@ -104,17 +104,17 @@
           </a:solidFill>
           <a:ln w="12700">
             <a:solidFill>
-              <a:srgbClr val="F8FAFC"/>
-            </a:solidFill>
-          </a:ln>
-        </p:spPr>
-        <p:txBody>
-          <a:bodyPr wrap="square" anchor="ctr"/>
-          <a:lstStyle/>
-          <a:p>
-            <a:pPr algn="ctr"/>
-            <a:r>
-              <a:rPr lang="en-US" sz="2100" b="1">
+              <a:srgbClr val="CBD5E1"/>
+            </a:solidFill>
+          </a:ln>
+        </p:spPr>
+        <p:txBody>
+          <a:bodyPr wrap="square" anchor="ctr"/>
+          <a:lstStyle/>
+          <a:p>
+            <a:pPr algn="ctr"/>
+            <a:r>
+              <a:rPr lang="zh-CN" sz="2100" b="1">
                 <a:solidFill>
                   <a:srgbClr val="242424"/>
                 </a:solidFill>
@@ -125,7 +125,7 @@
           <a:p>
             <a:pPr algn="ctr"/>
             <a:r>
-              <a:rPr lang="en-US" sz="2100" b="1">
+              <a:rPr lang="zh-CN" sz="2100" b="1">
                 <a:solidFill>
                   <a:srgbClr val="242424"/>
                 </a:solidFill>
@@ -136,7 +136,7 @@
           <a:p>
             <a:pPr algn="ctr"/>
             <a:r>
-              <a:rPr lang="en-US" sz="2100" b="1">
+              <a:rPr lang="zh-CN" sz="2100" b="1">
                 <a:solidFill>
                   <a:srgbClr val="242424"/>
                 </a:solidFill>
@@ -154,8 +154,8 @@
         </p:nvSpPr>
         <p:spPr>
           <a:xfrm>
-            <a:off x="1700000" y="1302474"/>
-            <a:ext cx="8792000" cy="190000"/>
+            <a:off x="670000" y="1302474"/>
+            <a:ext cx="10852000" cy="190000"/>
           </a:xfrm>
           <a:prstGeom prst="rect">
             <a:avLst/>
@@ -175,7 +175,7 @@
           <a:p>
             <a:pPr algn="ctr"/>
             <a:r>
-              <a:rPr lang="en-US" sz="850">
+              <a:rPr lang="zh-CN" sz="850">
                 <a:solidFill>
                   <a:srgbClr val="6B7280"/>
                 </a:solidFill>
@@ -186,7 +186,7 @@
           <a:p>
             <a:pPr algn="ctr"/>
             <a:r>
-              <a:rPr lang="en-US" sz="850">
+              <a:rPr lang="zh-CN" sz="850">
                 <a:solidFill>
                   <a:srgbClr val="6B7280"/>
                 </a:solidFill>
@@ -197,7 +197,7 @@
           <a:p>
             <a:pPr algn="ctr"/>
             <a:r>
-              <a:rPr lang="en-US" sz="850">
+              <a:rPr lang="zh-CN" sz="850">
                 <a:solidFill>
                   <a:srgbClr val="6B7280"/>
                 </a:solidFill>
@@ -236,7 +236,7 @@
           <a:p>
             <a:pPr algn="ctr"/>
             <a:r>
-              <a:rPr lang="en-US" sz="1000">
+              <a:rPr lang="zh-CN" sz="1000">
                 <a:solidFill>
                   <a:srgbClr val="242424"/>
                 </a:solidFill>
@@ -254,8 +254,8 @@
         </p:nvSpPr>
         <p:spPr>
           <a:xfrm>
-            <a:off x="804287" y="2225157"/>
-            <a:ext cx="1853398" cy="329108"/>
+            <a:off x="1024287" y="2225157"/>
+            <a:ext cx="630155" cy="329108"/>
           </a:xfrm>
           <a:prstGeom prst="roundRect">
             <a:avLst/>
@@ -275,7 +275,7 @@
           <a:p>
             <a:pPr algn="ctr"/>
             <a:r>
-              <a:rPr lang="en-US" sz="1100" b="1">
+              <a:rPr lang="zh-CN" sz="1100" b="1">
                 <a:solidFill>
                   <a:srgbClr val="FFFFFF"/>
                 </a:solidFill>
@@ -314,7 +314,7 @@
           <a:p>
             <a:pPr algn="ctr"/>
             <a:r>
-              <a:rPr lang="en-US" sz="1000">
+              <a:rPr lang="zh-CN" sz="1000">
                 <a:solidFill>
                   <a:srgbClr val="242424"/>
                 </a:solidFill>
@@ -332,8 +332,8 @@
         </p:nvSpPr>
         <p:spPr>
           <a:xfrm>
-            <a:off x="2986794" y="2225157"/>
-            <a:ext cx="1853398" cy="329108"/>
+            <a:off x="3206794" y="2225157"/>
+            <a:ext cx="630155" cy="329108"/>
           </a:xfrm>
           <a:prstGeom prst="roundRect">
             <a:avLst/>
@@ -353,7 +353,7 @@
           <a:p>
             <a:pPr algn="ctr"/>
             <a:r>
-              <a:rPr lang="en-US" sz="1100" b="1">
+              <a:rPr lang="zh-CN" sz="1100" b="1">
                 <a:solidFill>
                   <a:srgbClr val="FFFFFF"/>
                 </a:solidFill>
@@ -364,7 +364,7 @@
           <a:p>
             <a:pPr algn="ctr"/>
             <a:r>
-              <a:rPr lang="en-US" sz="1100" b="1">
+              <a:rPr lang="zh-CN" sz="1100" b="1">
                 <a:solidFill>
                   <a:srgbClr val="FFFFFF"/>
                 </a:solidFill>
@@ -403,7 +403,7 @@
           <a:p>
             <a:pPr algn="ctr"/>
             <a:r>
-              <a:rPr lang="en-US" sz="1000">
+              <a:rPr lang="zh-CN" sz="1000">
                 <a:solidFill>
                   <a:srgbClr val="242424"/>
                 </a:solidFill>
@@ -421,8 +421,8 @@
         </p:nvSpPr>
         <p:spPr>
           <a:xfrm>
-            <a:off x="5169300" y="2225157"/>
-            <a:ext cx="1853398" cy="329108"/>
+            <a:off x="5389300" y="2225157"/>
+            <a:ext cx="630155" cy="329108"/>
           </a:xfrm>
           <a:prstGeom prst="roundRect">
             <a:avLst/>
@@ -442,7 +442,7 @@
           <a:p>
             <a:pPr algn="ctr"/>
             <a:r>
-              <a:rPr lang="en-US" sz="1100" b="1">
+              <a:rPr lang="zh-CN" sz="1100" b="1">
                 <a:solidFill>
                   <a:srgbClr val="FFFFFF"/>
                 </a:solidFill>
@@ -481,7 +481,7 @@
           <a:p>
             <a:pPr algn="ctr"/>
             <a:r>
-              <a:rPr lang="en-US" sz="1000">
+              <a:rPr lang="zh-CN" sz="1000">
                 <a:solidFill>
                   <a:srgbClr val="242424"/>
                 </a:solidFill>
@@ -499,8 +499,8 @@
         </p:nvSpPr>
         <p:spPr>
           <a:xfrm>
-            <a:off x="7351807" y="2225157"/>
-            <a:ext cx="1853398" cy="329108"/>
+            <a:off x="7571807" y="2225157"/>
+            <a:ext cx="630155" cy="329108"/>
           </a:xfrm>
           <a:prstGeom prst="roundRect">
             <a:avLst/>
@@ -520,7 +520,7 @@
           <a:p>
             <a:pPr algn="ctr"/>
             <a:r>
-              <a:rPr lang="en-US" sz="1100" b="1">
+              <a:rPr lang="zh-CN" sz="1100" b="1">
                 <a:solidFill>
                   <a:srgbClr val="FFFFFF"/>
                 </a:solidFill>
@@ -559,7 +559,7 @@
           <a:p>
             <a:pPr algn="ctr"/>
             <a:r>
-              <a:rPr lang="en-US" sz="1000">
+              <a:rPr lang="zh-CN" sz="1000">
                 <a:solidFill>
                   <a:srgbClr val="242424"/>
                 </a:solidFill>
@@ -577,8 +577,8 @@
         </p:nvSpPr>
         <p:spPr>
           <a:xfrm>
-            <a:off x="9534314" y="2225157"/>
-            <a:ext cx="1853398" cy="329108"/>
+            <a:off x="9754314" y="2225157"/>
+            <a:ext cx="630155" cy="329108"/>
           </a:xfrm>
           <a:prstGeom prst="roundRect">
             <a:avLst/>
@@ -598,7 +598,7 @@
           <a:p>
             <a:pPr algn="ctr"/>
             <a:r>
-              <a:rPr lang="en-US" sz="1100" b="1">
+              <a:rPr lang="zh-CN" sz="1100" b="1">
                 <a:solidFill>
                   <a:srgbClr val="FFFFFF"/>
                 </a:solidFill>
@@ -868,6 +868,7 @@
             <a:solidFill>
               <a:srgbClr val="475569"/>
             </a:solidFill>
+            <a:prstDash val="dash"/>
             <a:headEnd type="triangle"/>
           </a:ln>
         </p:spPr>
@@ -901,7 +902,7 @@
           <a:p>
             <a:pPr algn="ctr"/>
             <a:r>
-              <a:rPr lang="en-US" sz="1050">
+              <a:rPr lang="zh-CN" sz="980">
                 <a:solidFill>
                   <a:srgbClr val="242424"/>
                 </a:solidFill>
@@ -912,7 +913,7 @@
           <a:p>
             <a:pPr algn="ctr"/>
             <a:r>
-              <a:rPr lang="en-US" sz="1050">
+              <a:rPr lang="zh-CN" sz="980">
                 <a:solidFill>
                   <a:srgbClr val="242424"/>
                 </a:solidFill>
@@ -951,7 +952,7 @@
           <a:p>
             <a:pPr algn="ctr"/>
             <a:r>
-              <a:rPr lang="en-US" sz="1050">
+              <a:rPr lang="zh-CN" sz="980">
                 <a:solidFill>
                   <a:srgbClr val="242424"/>
                 </a:solidFill>
@@ -962,7 +963,7 @@
           <a:p>
             <a:pPr algn="ctr"/>
             <a:r>
-              <a:rPr lang="en-US" sz="1050">
+              <a:rPr lang="zh-CN" sz="980">
                 <a:solidFill>
                   <a:srgbClr val="242424"/>
                 </a:solidFill>
@@ -1001,7 +1002,7 @@
           <a:p>
             <a:pPr algn="ctr"/>
             <a:r>
-              <a:rPr lang="en-US" sz="1050">
+              <a:rPr lang="zh-CN" sz="980">
                 <a:solidFill>
                   <a:srgbClr val="242424"/>
                 </a:solidFill>
@@ -1012,7 +1013,7 @@
           <a:p>
             <a:pPr algn="ctr"/>
             <a:r>
-              <a:rPr lang="en-US" sz="1050">
+              <a:rPr lang="zh-CN" sz="980">
                 <a:solidFill>
                   <a:srgbClr val="242424"/>
                 </a:solidFill>
@@ -1051,7 +1052,7 @@
           <a:p>
             <a:pPr algn="ctr"/>
             <a:r>
-              <a:rPr lang="en-US" sz="1050">
+              <a:rPr lang="zh-CN" sz="980">
                 <a:solidFill>
                   <a:srgbClr val="242424"/>
                 </a:solidFill>
@@ -1062,7 +1063,7 @@
           <a:p>
             <a:pPr algn="ctr"/>
             <a:r>
-              <a:rPr lang="en-US" sz="1050">
+              <a:rPr lang="zh-CN" sz="980">
                 <a:solidFill>
                   <a:srgbClr val="242424"/>
                 </a:solidFill>
@@ -1101,7 +1102,7 @@
           <a:p>
             <a:pPr algn="ctr"/>
             <a:r>
-              <a:rPr lang="en-US" sz="1050">
+              <a:rPr lang="zh-CN" sz="980">
                 <a:solidFill>
                   <a:srgbClr val="242424"/>
                 </a:solidFill>
@@ -1112,7 +1113,7 @@
           <a:p>
             <a:pPr algn="ctr"/>
             <a:r>
-              <a:rPr lang="en-US" sz="1050">
+              <a:rPr lang="zh-CN" sz="980">
                 <a:solidFill>
                   <a:srgbClr val="242424"/>
                 </a:solidFill>
@@ -1151,7 +1152,7 @@
           <a:p>
             <a:pPr algn="ctr"/>
             <a:r>
-              <a:rPr lang="en-US" sz="1050">
+              <a:rPr lang="zh-CN" sz="980">
                 <a:solidFill>
                   <a:srgbClr val="242424"/>
                 </a:solidFill>
@@ -1190,7 +1191,7 @@
           <a:p>
             <a:pPr algn="ctr"/>
             <a:r>
-              <a:rPr lang="en-US" sz="1050">
+              <a:rPr lang="zh-CN" sz="980">
                 <a:solidFill>
                   <a:srgbClr val="242424"/>
                 </a:solidFill>
@@ -1201,7 +1202,7 @@
           <a:p>
             <a:pPr algn="ctr"/>
             <a:r>
-              <a:rPr lang="en-US" sz="1050">
+              <a:rPr lang="zh-CN" sz="980">
                 <a:solidFill>
                   <a:srgbClr val="242424"/>
                 </a:solidFill>
@@ -1240,7 +1241,7 @@
           <a:p>
             <a:pPr algn="ctr"/>
             <a:r>
-              <a:rPr lang="en-US" sz="1050">
+              <a:rPr lang="zh-CN" sz="980">
                 <a:solidFill>
                   <a:srgbClr val="242424"/>
                 </a:solidFill>
@@ -1279,7 +1280,7 @@
           <a:p>
             <a:pPr algn="ctr"/>
             <a:r>
-              <a:rPr lang="en-US" sz="1050">
+              <a:rPr lang="zh-CN" sz="980">
                 <a:solidFill>
                   <a:srgbClr val="242424"/>
                 </a:solidFill>
@@ -1318,7 +1319,7 @@
           <a:p>
             <a:pPr algn="ctr"/>
             <a:r>
-              <a:rPr lang="en-US" sz="1050">
+              <a:rPr lang="zh-CN" sz="980">
                 <a:solidFill>
                   <a:srgbClr val="242424"/>
                 </a:solidFill>
@@ -1329,7 +1330,7 @@
           <a:p>
             <a:pPr algn="ctr"/>
             <a:r>
-              <a:rPr lang="en-US" sz="1050">
+              <a:rPr lang="zh-CN" sz="980">
                 <a:solidFill>
                   <a:srgbClr val="242424"/>
                 </a:solidFill>
@@ -1368,7 +1369,7 @@
           <a:p>
             <a:pPr algn="ctr"/>
             <a:r>
-              <a:rPr lang="en-US" sz="1050">
+              <a:rPr lang="zh-CN" sz="980">
                 <a:solidFill>
                   <a:srgbClr val="242424"/>
                 </a:solidFill>
@@ -1379,7 +1380,7 @@
           <a:p>
             <a:pPr algn="ctr"/>
             <a:r>
-              <a:rPr lang="en-US" sz="1050">
+              <a:rPr lang="zh-CN" sz="980">
                 <a:solidFill>
                   <a:srgbClr val="242424"/>
                 </a:solidFill>
@@ -1418,7 +1419,7 @@
           <a:p>
             <a:pPr algn="ctr"/>
             <a:r>
-              <a:rPr lang="en-US" sz="1050">
+              <a:rPr lang="zh-CN" sz="980">
                 <a:solidFill>
                   <a:srgbClr val="242424"/>
                 </a:solidFill>
@@ -1429,7 +1430,7 @@
           <a:p>
             <a:pPr algn="ctr"/>
             <a:r>
-              <a:rPr lang="en-US" sz="1050">
+              <a:rPr lang="zh-CN" sz="980">
                 <a:solidFill>
                   <a:srgbClr val="242424"/>
                 </a:solidFill>

</xml_diff>

<commit_message>
Release v0.3 evidence integrity and reliable rendering
</commit_message>
<xml_diff>
--- a/examples/agent-workflow-demo/outputs/tech-route.pptx
+++ b/examples/agent-workflow-demo/outputs/tech-route.pptx
@@ -194,7 +194,7 @@
         <p:spPr>
           <a:xfrm>
             <a:off x="804287" y="2225157"/>
-            <a:ext cx="1853398" cy="3360367"/>
+            <a:ext cx="1853398" cy="2615543"/>
           </a:xfrm>
           <a:prstGeom prst="roundRect">
             <a:avLst/>
@@ -272,7 +272,7 @@
         <p:spPr>
           <a:xfrm>
             <a:off x="2986794" y="2225157"/>
-            <a:ext cx="1853398" cy="3360367"/>
+            <a:ext cx="1853398" cy="2615543"/>
           </a:xfrm>
           <a:prstGeom prst="roundRect">
             <a:avLst/>
@@ -361,7 +361,7 @@
         <p:spPr>
           <a:xfrm>
             <a:off x="5169300" y="2225157"/>
-            <a:ext cx="1853398" cy="3360367"/>
+            <a:ext cx="1853398" cy="2615543"/>
           </a:xfrm>
           <a:prstGeom prst="roundRect">
             <a:avLst/>
@@ -439,7 +439,7 @@
         <p:spPr>
           <a:xfrm>
             <a:off x="7351807" y="2225157"/>
-            <a:ext cx="1853398" cy="3360367"/>
+            <a:ext cx="1853398" cy="2615543"/>
           </a:xfrm>
           <a:prstGeom prst="roundRect">
             <a:avLst/>
@@ -517,7 +517,7 @@
         <p:spPr>
           <a:xfrm>
             <a:off x="9534314" y="2225157"/>
-            <a:ext cx="1853398" cy="3360367"/>
+            <a:ext cx="1853398" cy="2615543"/>
           </a:xfrm>
           <a:prstGeom prst="roundRect">
             <a:avLst/>
@@ -594,7 +594,7 @@
         </p:nvCxnSpPr>
         <p:spPr>
           <a:xfrm>
-            <a:off x="2657685" y="3905340"/>
+            <a:off x="2657685" y="3532928"/>
             <a:ext cx="329108" cy="1"/>
           </a:xfrm>
           <a:prstGeom prst="line">
@@ -616,7 +616,7 @@
         </p:nvCxnSpPr>
         <p:spPr>
           <a:xfrm>
-            <a:off x="4840192" y="3905340"/>
+            <a:off x="4840192" y="3532928"/>
             <a:ext cx="329108" cy="1"/>
           </a:xfrm>
           <a:prstGeom prst="line">
@@ -638,7 +638,7 @@
         </p:nvCxnSpPr>
         <p:spPr>
           <a:xfrm>
-            <a:off x="7022699" y="3905340"/>
+            <a:off x="7022699" y="3532928"/>
             <a:ext cx="329108" cy="1"/>
           </a:xfrm>
           <a:prstGeom prst="line">
@@ -660,7 +660,7 @@
         </p:nvCxnSpPr>
         <p:spPr>
           <a:xfrm>
-            <a:off x="9205205" y="3905340"/>
+            <a:off x="9205205" y="3532928"/>
             <a:ext cx="329108" cy="1"/>
           </a:xfrm>
           <a:prstGeom prst="line">

</xml_diff>

<commit_message>
Release v0.3.0: evidence integrity and reliable rendering
Upgrade tech-route-maker with strict evidence verification, reliable editable rendering, multi-agent installation, refreshed examples, and cross-format quality checks.
</commit_message>
<xml_diff>
--- a/examples/agent-workflow-demo/outputs/tech-route.pptx
+++ b/examples/agent-workflow-demo/outputs/tech-route.pptx
@@ -194,7 +194,7 @@
         <p:spPr>
           <a:xfrm>
             <a:off x="804287" y="2225157"/>
-            <a:ext cx="1853398" cy="3360367"/>
+            <a:ext cx="1853398" cy="2615543"/>
           </a:xfrm>
           <a:prstGeom prst="roundRect">
             <a:avLst/>
@@ -272,7 +272,7 @@
         <p:spPr>
           <a:xfrm>
             <a:off x="2986794" y="2225157"/>
-            <a:ext cx="1853398" cy="3360367"/>
+            <a:ext cx="1853398" cy="2615543"/>
           </a:xfrm>
           <a:prstGeom prst="roundRect">
             <a:avLst/>
@@ -361,7 +361,7 @@
         <p:spPr>
           <a:xfrm>
             <a:off x="5169300" y="2225157"/>
-            <a:ext cx="1853398" cy="3360367"/>
+            <a:ext cx="1853398" cy="2615543"/>
           </a:xfrm>
           <a:prstGeom prst="roundRect">
             <a:avLst/>
@@ -439,7 +439,7 @@
         <p:spPr>
           <a:xfrm>
             <a:off x="7351807" y="2225157"/>
-            <a:ext cx="1853398" cy="3360367"/>
+            <a:ext cx="1853398" cy="2615543"/>
           </a:xfrm>
           <a:prstGeom prst="roundRect">
             <a:avLst/>
@@ -517,7 +517,7 @@
         <p:spPr>
           <a:xfrm>
             <a:off x="9534314" y="2225157"/>
-            <a:ext cx="1853398" cy="3360367"/>
+            <a:ext cx="1853398" cy="2615543"/>
           </a:xfrm>
           <a:prstGeom prst="roundRect">
             <a:avLst/>
@@ -594,7 +594,7 @@
         </p:nvCxnSpPr>
         <p:spPr>
           <a:xfrm>
-            <a:off x="2657685" y="3905340"/>
+            <a:off x="2657685" y="3532928"/>
             <a:ext cx="329108" cy="1"/>
           </a:xfrm>
           <a:prstGeom prst="line">
@@ -616,7 +616,7 @@
         </p:nvCxnSpPr>
         <p:spPr>
           <a:xfrm>
-            <a:off x="4840192" y="3905340"/>
+            <a:off x="4840192" y="3532928"/>
             <a:ext cx="329108" cy="1"/>
           </a:xfrm>
           <a:prstGeom prst="line">
@@ -638,7 +638,7 @@
         </p:nvCxnSpPr>
         <p:spPr>
           <a:xfrm>
-            <a:off x="7022699" y="3905340"/>
+            <a:off x="7022699" y="3532928"/>
             <a:ext cx="329108" cy="1"/>
           </a:xfrm>
           <a:prstGeom prst="line">
@@ -660,7 +660,7 @@
         </p:nvCxnSpPr>
         <p:spPr>
           <a:xfrm>
-            <a:off x="9205205" y="3905340"/>
+            <a:off x="9205205" y="3532928"/>
             <a:ext cx="329108" cy="1"/>
           </a:xfrm>
           <a:prstGeom prst="line">

</xml_diff>